<commit_message>
Update Week 9 archived deck with Alexis's red-mask photo slide
</commit_message>
<xml_diff>
--- a/Weekly Reports/Week 9/Self-Driving-RC-Car - Week 9.pptx
+++ b/Weekly Reports/Week 9/Self-Driving-RC-Car - Week 9.pptx
@@ -18,6 +18,7 @@
     <p:sldId id="266" r:id="rId16"/>
     <p:sldId id="267" r:id="rId17"/>
     <p:sldId id="268" r:id="rId18"/>
+    <p:sldId id="269" r:id="rId19"/>
   </p:sldIdLst>
   <p:sldSz cx="12192000" cy="6858000"/>
   <p:notesSz cx="6858000" cy="9144000"/>
@@ -3457,6 +3458,658 @@
                 <a:ea typeface="Aptos Display"/>
                 <a:cs typeface="Aptos Display"/>
               </a:rPr>
+              <a:t>ROS 2 could split our pipeline into eight nodes</a:t>
+            </a:r>
+          </a:p>
+        </p:txBody>
+      </p:sp>
+      <p:sp>
+        <p:nvSpPr>
+          <p:cNvPr id="3" name="Subtitle"/>
+          <p:cNvSpPr txBox="1"/>
+          <p:nvPr/>
+        </p:nvSpPr>
+        <p:spPr>
+          <a:xfrm>
+            <a:off x="786384" y="1024128"/>
+            <a:ext cx="10607040" cy="365760"/>
+          </a:xfrm>
+          <a:prstGeom prst="rect">
+            <a:avLst/>
+          </a:prstGeom>
+          <a:noFill/>
+        </p:spPr>
+        <p:txBody>
+          <a:bodyPr wrap="square" lIns="0" tIns="0" rIns="0" bIns="0" anchor="t">
+            <a:noAutofit/>
+          </a:bodyPr>
+          <a:lstStyle/>
+          <a:p>
+            <a:pPr marL="0" indent="0" algn="l">
+              <a:spcBef>
+                <a:spcPts val="0"/>
+              </a:spcBef>
+              <a:buNone/>
+            </a:pPr>
+            <a:r>
+              <a:rPr lang="en-US" sz="1500" b="1" dirty="0">
+                <a:solidFill>
+                  <a:srgbClr val="000000"/>
+                </a:solidFill>
+                <a:latin typeface="Aptos"/>
+                <a:ea typeface="Aptos"/>
+                <a:cs typeface="Aptos"/>
+              </a:rPr>
+              <a:t>Preliminary node structure for the car; each node does one job</a:t>
+            </a:r>
+          </a:p>
+        </p:txBody>
+      </p:sp>
+      <p:sp>
+        <p:nvSpPr>
+          <p:cNvPr id="4" name="Nodes"/>
+          <p:cNvSpPr txBox="1"/>
+          <p:nvPr/>
+        </p:nvSpPr>
+        <p:spPr>
+          <a:xfrm>
+            <a:off x="786384" y="1719072"/>
+            <a:ext cx="6309360" cy="384048"/>
+          </a:xfrm>
+          <a:prstGeom prst="rect">
+            <a:avLst/>
+          </a:prstGeom>
+          <a:noFill/>
+        </p:spPr>
+        <p:txBody>
+          <a:bodyPr wrap="square" lIns="0" tIns="0" rIns="0" bIns="0" anchor="t">
+            <a:noAutofit/>
+          </a:bodyPr>
+          <a:lstStyle/>
+          <a:p>
+            <a:pPr marL="0" indent="0" algn="l">
+              <a:spcBef>
+                <a:spcPts val="0"/>
+              </a:spcBef>
+              <a:buNone/>
+            </a:pPr>
+            <a:r>
+              <a:rPr lang="en-US" sz="1950" b="1" dirty="0">
+                <a:solidFill>
+                  <a:srgbClr val="30669D"/>
+                </a:solidFill>
+                <a:latin typeface="Aptos"/>
+                <a:ea typeface="Aptos"/>
+                <a:cs typeface="Aptos"/>
+              </a:rPr>
+              <a:t>Nodes</a:t>
+            </a:r>
+          </a:p>
+        </p:txBody>
+      </p:sp>
+      <p:sp>
+        <p:nvSpPr>
+          <p:cNvPr id="5" name="Node list"/>
+          <p:cNvSpPr txBox="1"/>
+          <p:nvPr/>
+        </p:nvSpPr>
+        <p:spPr>
+          <a:xfrm>
+            <a:off x="786384" y="2240280"/>
+            <a:ext cx="6309360" cy="4023360"/>
+          </a:xfrm>
+          <a:prstGeom prst="rect">
+            <a:avLst/>
+          </a:prstGeom>
+          <a:noFill/>
+        </p:spPr>
+        <p:txBody>
+          <a:bodyPr wrap="square" lIns="0" tIns="0" rIns="0" bIns="0" anchor="t">
+            <a:noAutofit/>
+          </a:bodyPr>
+          <a:lstStyle/>
+          <a:p>
+            <a:pPr marL="228600" indent="-228600" algn="l">
+              <a:spcBef>
+                <a:spcPts val="0"/>
+              </a:spcBef>
+              <a:buClr>
+                <a:srgbClr val="30669D"/>
+              </a:buClr>
+              <a:buFont typeface="Arial"/>
+              <a:buChar char="•"/>
+            </a:pPr>
+            <a:r>
+              <a:rPr lang="en-US" sz="1600" b="1" dirty="0">
+                <a:solidFill>
+                  <a:srgbClr val="000000"/>
+                </a:solidFill>
+                <a:latin typeface="Aptos"/>
+                <a:ea typeface="Aptos"/>
+                <a:cs typeface="Aptos"/>
+              </a:rPr>
+              <a:t>Camera: </a:t>
+            </a:r>
+            <a:r>
+              <a:rPr lang="en-US" sz="1600" b="0" dirty="0">
+                <a:solidFill>
+                  <a:srgbClr val="000000"/>
+                </a:solidFill>
+                <a:latin typeface="Aptos"/>
+                <a:ea typeface="Aptos"/>
+                <a:cs typeface="Aptos"/>
+              </a:rPr>
+              <a:t>streams video from the Pi Camera Module 3</a:t>
+            </a:r>
+          </a:p>
+          <a:p>
+            <a:pPr marL="228600" indent="-228600" algn="l">
+              <a:spcBef>
+                <a:spcPts val="700"/>
+              </a:spcBef>
+              <a:buClr>
+                <a:srgbClr val="30669D"/>
+              </a:buClr>
+              <a:buFont typeface="Arial"/>
+              <a:buChar char="•"/>
+            </a:pPr>
+            <a:r>
+              <a:rPr lang="en-US" sz="1600" b="1" dirty="0">
+                <a:solidFill>
+                  <a:srgbClr val="000000"/>
+                </a:solidFill>
+                <a:latin typeface="Aptos"/>
+                <a:ea typeface="Aptos"/>
+                <a:cs typeface="Aptos"/>
+              </a:rPr>
+              <a:t>Sign detector: </a:t>
+            </a:r>
+            <a:r>
+              <a:rPr lang="en-US" sz="1600" b="0" dirty="0">
+                <a:solidFill>
+                  <a:srgbClr val="000000"/>
+                </a:solidFill>
+                <a:latin typeface="Aptos"/>
+                <a:ea typeface="Aptos"/>
+                <a:cs typeface="Aptos"/>
+              </a:rPr>
+              <a:t>runs the vision model and reports each sign’s type, confidence and position</a:t>
+            </a:r>
+          </a:p>
+          <a:p>
+            <a:pPr marL="228600" indent="-228600" algn="l">
+              <a:spcBef>
+                <a:spcPts val="700"/>
+              </a:spcBef>
+              <a:buClr>
+                <a:srgbClr val="30669D"/>
+              </a:buClr>
+              <a:buFont typeface="Arial"/>
+              <a:buChar char="•"/>
+            </a:pPr>
+            <a:r>
+              <a:rPr lang="en-US" sz="1600" b="1" dirty="0">
+                <a:solidFill>
+                  <a:srgbClr val="000000"/>
+                </a:solidFill>
+                <a:latin typeface="Aptos"/>
+                <a:ea typeface="Aptos"/>
+                <a:cs typeface="Aptos"/>
+              </a:rPr>
+              <a:t>Line sensor: </a:t>
+            </a:r>
+            <a:r>
+              <a:rPr lang="en-US" sz="1600" b="0" dirty="0">
+                <a:solidFill>
+                  <a:srgbClr val="000000"/>
+                </a:solidFill>
+                <a:latin typeface="Aptos"/>
+                <a:ea typeface="Aptos"/>
+                <a:cs typeface="Aptos"/>
+              </a:rPr>
+              <a:t>tracks the lane lines with TCRT5000 IR sensors</a:t>
+            </a:r>
+          </a:p>
+          <a:p>
+            <a:pPr marL="228600" indent="-228600" algn="l">
+              <a:spcBef>
+                <a:spcPts val="700"/>
+              </a:spcBef>
+              <a:buClr>
+                <a:srgbClr val="30669D"/>
+              </a:buClr>
+              <a:buFont typeface="Arial"/>
+              <a:buChar char="•"/>
+            </a:pPr>
+            <a:r>
+              <a:rPr lang="en-US" sz="1600" b="1" dirty="0">
+                <a:solidFill>
+                  <a:srgbClr val="000000"/>
+                </a:solidFill>
+                <a:latin typeface="Aptos"/>
+                <a:ea typeface="Aptos"/>
+                <a:cs typeface="Aptos"/>
+              </a:rPr>
+              <a:t>IMU: </a:t>
+            </a:r>
+            <a:r>
+              <a:rPr lang="en-US" sz="1600" b="0" dirty="0">
+                <a:solidFill>
+                  <a:srgbClr val="000000"/>
+                </a:solidFill>
+                <a:latin typeface="Aptos"/>
+                <a:ea typeface="Aptos"/>
+                <a:cs typeface="Aptos"/>
+              </a:rPr>
+              <a:t>reports turning and motion; detects if the car is stuck</a:t>
+            </a:r>
+          </a:p>
+          <a:p>
+            <a:pPr marL="228600" indent="-228600" algn="l">
+              <a:spcBef>
+                <a:spcPts val="700"/>
+              </a:spcBef>
+              <a:buClr>
+                <a:srgbClr val="30669D"/>
+              </a:buClr>
+              <a:buFont typeface="Arial"/>
+              <a:buChar char="•"/>
+            </a:pPr>
+            <a:r>
+              <a:rPr lang="en-US" sz="1600" b="1" dirty="0">
+                <a:solidFill>
+                  <a:srgbClr val="000000"/>
+                </a:solidFill>
+                <a:latin typeface="Aptos"/>
+                <a:ea typeface="Aptos"/>
+                <a:cs typeface="Aptos"/>
+              </a:rPr>
+              <a:t>Behavior: </a:t>
+            </a:r>
+            <a:r>
+              <a:rPr lang="en-US" sz="1600" b="0" dirty="0">
+                <a:solidFill>
+                  <a:srgbClr val="000000"/>
+                </a:solidFill>
+                <a:latin typeface="Aptos"/>
+                <a:ea typeface="Aptos"/>
+                <a:cs typeface="Aptos"/>
+              </a:rPr>
+              <a:t>a state machine that turns signs, lane position and IMU data into driving decisions</a:t>
+            </a:r>
+          </a:p>
+          <a:p>
+            <a:pPr marL="228600" indent="-228600" algn="l">
+              <a:spcBef>
+                <a:spcPts val="700"/>
+              </a:spcBef>
+              <a:buClr>
+                <a:srgbClr val="30669D"/>
+              </a:buClr>
+              <a:buFont typeface="Arial"/>
+              <a:buChar char="•"/>
+            </a:pPr>
+            <a:r>
+              <a:rPr lang="en-US" sz="1600" b="1" dirty="0">
+                <a:solidFill>
+                  <a:srgbClr val="000000"/>
+                </a:solidFill>
+                <a:latin typeface="Aptos"/>
+                <a:ea typeface="Aptos"/>
+                <a:cs typeface="Aptos"/>
+              </a:rPr>
+              <a:t>Motor driver: </a:t>
+            </a:r>
+            <a:r>
+              <a:rPr lang="en-US" sz="1600" b="0" dirty="0">
+                <a:solidFill>
+                  <a:srgbClr val="000000"/>
+                </a:solidFill>
+                <a:latin typeface="Aptos"/>
+                <a:ea typeface="Aptos"/>
+                <a:cs typeface="Aptos"/>
+              </a:rPr>
+              <a:t>drives the wheels through the Waveshare HAT and stops if commands stop arriving</a:t>
+            </a:r>
+          </a:p>
+          <a:p>
+            <a:pPr marL="228600" indent="-228600" algn="l">
+              <a:spcBef>
+                <a:spcPts val="700"/>
+              </a:spcBef>
+              <a:buClr>
+                <a:srgbClr val="30669D"/>
+              </a:buClr>
+              <a:buFont typeface="Arial"/>
+              <a:buChar char="•"/>
+            </a:pPr>
+            <a:r>
+              <a:rPr lang="en-US" sz="1600" b="1" dirty="0">
+                <a:solidFill>
+                  <a:srgbClr val="000000"/>
+                </a:solidFill>
+                <a:latin typeface="Aptos"/>
+                <a:ea typeface="Aptos"/>
+                <a:cs typeface="Aptos"/>
+              </a:rPr>
+              <a:t>LCD: </a:t>
+            </a:r>
+            <a:r>
+              <a:rPr lang="en-US" sz="1600" b="0" dirty="0">
+                <a:solidFill>
+                  <a:srgbClr val="000000"/>
+                </a:solidFill>
+                <a:latin typeface="Aptos"/>
+                <a:ea typeface="Aptos"/>
+                <a:cs typeface="Aptos"/>
+              </a:rPr>
+              <a:t>shows the car’s state and the last sign detected</a:t>
+            </a:r>
+          </a:p>
+          <a:p>
+            <a:pPr marL="228600" indent="-228600" algn="l">
+              <a:spcBef>
+                <a:spcPts val="700"/>
+              </a:spcBef>
+              <a:buClr>
+                <a:srgbClr val="30669D"/>
+              </a:buClr>
+              <a:buFont typeface="Arial"/>
+              <a:buChar char="•"/>
+            </a:pPr>
+            <a:r>
+              <a:rPr lang="en-US" sz="1600" b="1" dirty="0">
+                <a:solidFill>
+                  <a:srgbClr val="000000"/>
+                </a:solidFill>
+                <a:latin typeface="Aptos"/>
+                <a:ea typeface="Aptos"/>
+                <a:cs typeface="Aptos"/>
+              </a:rPr>
+              <a:t>Teleop: </a:t>
+            </a:r>
+            <a:r>
+              <a:rPr lang="en-US" sz="1600" b="0" dirty="0">
+                <a:solidFill>
+                  <a:srgbClr val="000000"/>
+                </a:solidFill>
+                <a:latin typeface="Aptos"/>
+                <a:ea typeface="Aptos"/>
+                <a:cs typeface="Aptos"/>
+              </a:rPr>
+              <a:t>lets a person take over and drive manually</a:t>
+            </a:r>
+          </a:p>
+        </p:txBody>
+      </p:sp>
+      <p:sp>
+        <p:nvSpPr>
+          <p:cNvPr id="6" name="Why ROS 2"/>
+          <p:cNvSpPr txBox="1"/>
+          <p:nvPr/>
+        </p:nvSpPr>
+        <p:spPr>
+          <a:xfrm>
+            <a:off x="7635240" y="1719072"/>
+            <a:ext cx="3794760" cy="384048"/>
+          </a:xfrm>
+          <a:prstGeom prst="rect">
+            <a:avLst/>
+          </a:prstGeom>
+          <a:noFill/>
+        </p:spPr>
+        <p:txBody>
+          <a:bodyPr wrap="square" lIns="0" tIns="0" rIns="0" bIns="0" anchor="t">
+            <a:noAutofit/>
+          </a:bodyPr>
+          <a:lstStyle/>
+          <a:p>
+            <a:pPr marL="0" indent="0" algn="l">
+              <a:spcBef>
+                <a:spcPts val="0"/>
+              </a:spcBef>
+              <a:buNone/>
+            </a:pPr>
+            <a:r>
+              <a:rPr lang="en-US" sz="1950" b="1" dirty="0">
+                <a:solidFill>
+                  <a:srgbClr val="30669D"/>
+                </a:solidFill>
+                <a:latin typeface="Aptos"/>
+                <a:ea typeface="Aptos"/>
+                <a:cs typeface="Aptos"/>
+              </a:rPr>
+              <a:t>Why ROS 2</a:t>
+            </a:r>
+          </a:p>
+        </p:txBody>
+      </p:sp>
+      <p:sp>
+        <p:nvSpPr>
+          <p:cNvPr id="7" name="Why ROS 2 list"/>
+          <p:cNvSpPr txBox="1"/>
+          <p:nvPr/>
+        </p:nvSpPr>
+        <p:spPr>
+          <a:xfrm>
+            <a:off x="7635240" y="2240280"/>
+            <a:ext cx="3794760" cy="2103120"/>
+          </a:xfrm>
+          <a:prstGeom prst="rect">
+            <a:avLst/>
+          </a:prstGeom>
+          <a:noFill/>
+        </p:spPr>
+        <p:txBody>
+          <a:bodyPr wrap="square" lIns="0" tIns="0" rIns="0" bIns="0" anchor="t">
+            <a:noAutofit/>
+          </a:bodyPr>
+          <a:lstStyle/>
+          <a:p>
+            <a:pPr marL="228600" indent="-228600" algn="l">
+              <a:spcBef>
+                <a:spcPts val="0"/>
+              </a:spcBef>
+              <a:buClr>
+                <a:srgbClr val="30669D"/>
+              </a:buClr>
+              <a:buFont typeface="Arial"/>
+              <a:buChar char="•"/>
+            </a:pPr>
+            <a:r>
+              <a:rPr lang="en-US" sz="1600" b="0" dirty="0">
+                <a:solidFill>
+                  <a:srgbClr val="000000"/>
+                </a:solidFill>
+                <a:latin typeface="Aptos"/>
+                <a:ea typeface="Aptos"/>
+                <a:cs typeface="Aptos"/>
+              </a:rPr>
+              <a:t>Each teammate can own a node without touching the others</a:t>
+            </a:r>
+          </a:p>
+          <a:p>
+            <a:pPr marL="228600" indent="-228600" algn="l">
+              <a:spcBef>
+                <a:spcPts val="900"/>
+              </a:spcBef>
+              <a:buClr>
+                <a:srgbClr val="30669D"/>
+              </a:buClr>
+              <a:buFont typeface="Arial"/>
+              <a:buChar char="•"/>
+            </a:pPr>
+            <a:r>
+              <a:rPr lang="en-US" sz="1600" b="0" dirty="0">
+                <a:solidFill>
+                  <a:srgbClr val="000000"/>
+                </a:solidFill>
+                <a:latin typeface="Aptos"/>
+                <a:ea typeface="Aptos"/>
+                <a:cs typeface="Aptos"/>
+              </a:rPr>
+              <a:t>Recorded drives can be replayed to test without the car</a:t>
+            </a:r>
+          </a:p>
+          <a:p>
+            <a:pPr marL="228600" indent="-228600" algn="l">
+              <a:spcBef>
+                <a:spcPts val="900"/>
+              </a:spcBef>
+              <a:buClr>
+                <a:srgbClr val="30669D"/>
+              </a:buClr>
+              <a:buFont typeface="Arial"/>
+              <a:buChar char="•"/>
+            </a:pPr>
+            <a:r>
+              <a:rPr lang="en-US" sz="1600" b="0" dirty="0">
+                <a:solidFill>
+                  <a:srgbClr val="000000"/>
+                </a:solidFill>
+                <a:latin typeface="Aptos"/>
+                <a:ea typeface="Aptos"/>
+                <a:cs typeface="Aptos"/>
+              </a:rPr>
+              <a:t>Laptops can watch the camera feed and topics live</a:t>
+            </a:r>
+          </a:p>
+        </p:txBody>
+      </p:sp>
+      <p:sp>
+        <p:nvSpPr>
+          <p:cNvPr id="8" name="Trade-off"/>
+          <p:cNvSpPr txBox="1"/>
+          <p:nvPr/>
+        </p:nvSpPr>
+        <p:spPr>
+          <a:xfrm>
+            <a:off x="7635240" y="4434840"/>
+            <a:ext cx="3794760" cy="384048"/>
+          </a:xfrm>
+          <a:prstGeom prst="rect">
+            <a:avLst/>
+          </a:prstGeom>
+          <a:noFill/>
+        </p:spPr>
+        <p:txBody>
+          <a:bodyPr wrap="square" lIns="0" tIns="0" rIns="0" bIns="0" anchor="t">
+            <a:noAutofit/>
+          </a:bodyPr>
+          <a:lstStyle/>
+          <a:p>
+            <a:pPr marL="0" indent="0" algn="l">
+              <a:spcBef>
+                <a:spcPts val="0"/>
+              </a:spcBef>
+              <a:buNone/>
+            </a:pPr>
+            <a:r>
+              <a:rPr lang="en-US" sz="1950" b="1" dirty="0">
+                <a:solidFill>
+                  <a:srgbClr val="30669D"/>
+                </a:solidFill>
+                <a:latin typeface="Aptos"/>
+                <a:ea typeface="Aptos"/>
+                <a:cs typeface="Aptos"/>
+              </a:rPr>
+              <a:t>Trade-off</a:t>
+            </a:r>
+          </a:p>
+        </p:txBody>
+      </p:sp>
+      <p:sp>
+        <p:nvSpPr>
+          <p:cNvPr id="9" name="Trade-off text"/>
+          <p:cNvSpPr txBox="1"/>
+          <p:nvPr/>
+        </p:nvSpPr>
+        <p:spPr>
+          <a:xfrm>
+            <a:off x="7635240" y="4956048"/>
+            <a:ext cx="3794760" cy="1280160"/>
+          </a:xfrm>
+          <a:prstGeom prst="rect">
+            <a:avLst/>
+          </a:prstGeom>
+          <a:noFill/>
+        </p:spPr>
+        <p:txBody>
+          <a:bodyPr wrap="square" lIns="0" tIns="0" rIns="0" bIns="0" anchor="t">
+            <a:noAutofit/>
+          </a:bodyPr>
+          <a:lstStyle/>
+          <a:p>
+            <a:pPr marL="0" indent="0" algn="l">
+              <a:spcBef>
+                <a:spcPts val="0"/>
+              </a:spcBef>
+              <a:buNone/>
+            </a:pPr>
+            <a:r>
+              <a:rPr lang="en-US" sz="1600" b="0" dirty="0">
+                <a:solidFill>
+                  <a:srgbClr val="000000"/>
+                </a:solidFill>
+                <a:latin typeface="Aptos"/>
+                <a:ea typeface="Aptos"/>
+                <a:cs typeface="Aptos"/>
+              </a:rPr>
+              <a:t>More upfront setup than a single script, including a custom Docker build for the CM5 camera</a:t>
+            </a:r>
+          </a:p>
+        </p:txBody>
+      </p:sp>
+    </p:spTree>
+  </p:cSld>
+  <p:clrMapOvr>
+    <a:masterClrMapping/>
+  </p:clrMapOvr>
+</p:sld>
+</file>
+
+<file path=ppt/slides/slide11.xml><?xml version="1.0" encoding="utf-8"?>
+<p:sld xmlns:a="http://schemas.openxmlformats.org/drawingml/2006/main" xmlns:p="http://schemas.openxmlformats.org/presentationml/2006/main" xmlns:r="http://schemas.openxmlformats.org/officeDocument/2006/relationships">
+  <p:cSld>
+    <p:spTree>
+      <p:nvGrpSpPr>
+        <p:cNvPr id="1" name=""/>
+        <p:cNvGrpSpPr/>
+        <p:nvPr/>
+      </p:nvGrpSpPr>
+      <p:grpSpPr/>
+      <p:sp>
+        <p:nvSpPr>
+          <p:cNvPr id="2" name="Title"/>
+          <p:cNvSpPr>
+            <a:spLocks noGrp="1"/>
+          </p:cNvSpPr>
+          <p:nvPr>
+            <p:ph type="title"/>
+          </p:nvPr>
+        </p:nvSpPr>
+        <p:spPr>
+          <a:xfrm>
+            <a:off x="768096" y="365760"/>
+            <a:ext cx="10789920" cy="658368"/>
+          </a:xfrm>
+        </p:spPr>
+        <p:txBody>
+          <a:bodyPr lIns="0" tIns="0" rIns="0" bIns="0" anchor="b">
+            <a:normAutofit/>
+          </a:bodyPr>
+          <a:lstStyle/>
+          <a:p>
+            <a:pPr algn="l"/>
+            <a:r>
+              <a:rPr lang="en-US" sz="3500" b="0" dirty="0">
+                <a:solidFill>
+                  <a:srgbClr val="000000"/>
+                </a:solidFill>
+                <a:latin typeface="Aptos Display"/>
+                <a:ea typeface="Aptos Display"/>
+                <a:cs typeface="Aptos Display"/>
+              </a:rPr>
               <a:t>The behavior node makes every driving decision</a:t>
             </a:r>
           </a:p>
@@ -4474,7 +5127,7 @@
 </p:sld>
 </file>
 
-<file path=ppt/slides/slide11.xml><?xml version="1.0" encoding="utf-8"?>
+<file path=ppt/slides/slide12.xml><?xml version="1.0" encoding="utf-8"?>
 <p:sld xmlns:a="http://schemas.openxmlformats.org/drawingml/2006/main" xmlns:p="http://schemas.openxmlformats.org/presentationml/2006/main" xmlns:r="http://schemas.openxmlformats.org/officeDocument/2006/relationships">
   <p:cSld>
     <p:spTree>
@@ -4646,7 +5299,7 @@
 </p:sld>
 </file>
 
-<file path=ppt/slides/slide12.xml><?xml version="1.0" encoding="utf-8"?>
+<file path=ppt/slides/slide13.xml><?xml version="1.0" encoding="utf-8"?>
 <p:sld xmlns:a="http://schemas.openxmlformats.org/drawingml/2006/main" xmlns:p="http://schemas.openxmlformats.org/presentationml/2006/main" xmlns:r="http://schemas.openxmlformats.org/officeDocument/2006/relationships">
   <p:cSld>
     <p:spTree>
@@ -4694,7 +5347,7 @@
 </p:sld>
 </file>
 
-<file path=ppt/slides/slide13.xml><?xml version="1.0" encoding="utf-8"?>
+<file path=ppt/slides/slide14.xml><?xml version="1.0" encoding="utf-8"?>
 <p:sld xmlns:a="http://schemas.openxmlformats.org/drawingml/2006/main" xmlns:p="http://schemas.openxmlformats.org/presentationml/2006/main" xmlns:r="http://schemas.openxmlformats.org/officeDocument/2006/relationships">
   <p:cSld>
     <p:spTree>
@@ -13158,13 +13811,7 @@
       <p:grpSpPr/>
       <p:sp>
         <p:nvSpPr>
-          <p:cNvPr id="2" name="Title 1">
-            <a:extLst>
-              <a:ext uri="{FF2B5EF4-FFF2-40B4-BE49-F238E27FC236}">
-                <a16:creationId xmlns:a16="http://schemas.microsoft.com/office/drawing/2014/main" id="{30AEBF44-7FD5-A705-80AC-D5F6B809A46E}"/>
-              </a:ext>
-            </a:extLst>
-          </p:cNvPr>
+          <p:cNvPr id="59" name="PlaceHolder 1"/>
           <p:cNvSpPr>
             <a:spLocks noGrp="1"/>
           </p:cNvSpPr>
@@ -13172,113 +13819,418 @@
             <p:ph type="title"/>
           </p:nvPr>
         </p:nvSpPr>
-        <p:spPr/>
+        <p:spPr>
+          <a:xfrm>
+            <a:off x="838080" y="365040"/>
+            <a:ext cx="10515240" cy="1325160"/>
+          </a:xfrm>
+          <a:prstGeom prst="rect">
+            <a:avLst/>
+          </a:prstGeom>
+          <a:noFill/>
+          <a:ln w="0">
+            <a:noFill/>
+          </a:ln>
+        </p:spPr>
         <p:txBody>
-          <a:bodyPr/>
-          <a:lstStyle/>
-          <a:p>
-            <a:r>
-              <a:rPr lang="en-US" dirty="0"/>
+          <a:bodyPr lIns="91440" tIns="45720" rIns="91440" bIns="45720" anchor="ctr">
+            <a:noAutofit/>
+          </a:bodyPr>
+          <a:p>
+            <a:pPr indent="0" algn="l" defTabSz="914400">
+              <a:lnSpc>
+                <a:spcPct val="90000"/>
+              </a:lnSpc>
+              <a:buNone/>
+            </a:pPr>
+            <a:r>
+              <a:rPr lang="en-US" sz="4400" b="0" u="none" strike="noStrike">
+                <a:solidFill>
+                  <a:schemeClr val="dk1"/>
+                </a:solidFill>
+                <a:effectLst/>
+                <a:uFillTx/>
+                <a:latin typeface="Aptos Display"/>
+              </a:rPr>
               <a:t>Alexis Perez</a:t>
             </a:r>
+            <a:endParaRPr lang="en-US" sz="4400" b="0" u="none" strike="noStrike">
+              <a:solidFill>
+                <a:schemeClr val="dk1"/>
+              </a:solidFill>
+              <a:effectLst/>
+              <a:uFillTx/>
+              <a:latin typeface="Aptos Display"/>
+            </a:endParaRPr>
           </a:p>
         </p:txBody>
       </p:sp>
       <p:sp>
         <p:nvSpPr>
-          <p:cNvPr id="3" name="Content Placeholder 2">
-            <a:extLst>
-              <a:ext uri="{FF2B5EF4-FFF2-40B4-BE49-F238E27FC236}">
-                <a16:creationId xmlns:a16="http://schemas.microsoft.com/office/drawing/2014/main" id="{3F6BF837-7A7D-A6A3-574B-020760331940}"/>
-              </a:ext>
-            </a:extLst>
-          </p:cNvPr>
+          <p:cNvPr id="60" name="PlaceHolder 2"/>
           <p:cNvSpPr>
             <a:spLocks noGrp="1"/>
           </p:cNvSpPr>
           <p:nvPr>
-            <p:ph idx="1"/>
+            <p:ph/>
           </p:nvPr>
         </p:nvSpPr>
-        <p:spPr/>
+        <p:spPr>
+          <a:xfrm>
+            <a:off x="838080" y="1825560"/>
+            <a:ext cx="10515240" cy="4350960"/>
+          </a:xfrm>
+          <a:prstGeom prst="rect">
+            <a:avLst/>
+          </a:prstGeom>
+          <a:noFill/>
+          <a:ln w="0">
+            <a:noFill/>
+          </a:ln>
+        </p:spPr>
         <p:txBody>
-          <a:bodyPr>
-            <a:normAutofit lnSpcReduction="10000"/>
+          <a:bodyPr lIns="91440" tIns="45720" rIns="91440" bIns="45720" anchor="t">
+            <a:normAutofit lnSpcReduction="9999"/>
           </a:bodyPr>
-          <a:lstStyle/>
-          <a:p>
-            <a:r>
-              <a:rPr lang="en-US" b="1" dirty="0"/>
+          <a:p>
+            <a:pPr marL="228600" indent="-228600" algn="l" defTabSz="914400">
+              <a:lnSpc>
+                <a:spcPct val="90000"/>
+              </a:lnSpc>
+              <a:spcBef>
+                <a:spcPts val="1001"/>
+              </a:spcBef>
+              <a:buClr>
+                <a:srgbClr val="000000"/>
+              </a:buClr>
+              <a:buFont typeface="Arial"/>
+              <a:buChar char="•"/>
+            </a:pPr>
+            <a:r>
+              <a:rPr lang="en-US" sz="2800" b="1" u="none" strike="noStrike">
+                <a:solidFill>
+                  <a:schemeClr val="dk1"/>
+                </a:solidFill>
+                <a:effectLst/>
+                <a:uFillTx/>
+                <a:latin typeface="Aptos"/>
+              </a:rPr>
               <a:t>Goals for the week</a:t>
             </a:r>
-          </a:p>
-          <a:p>
-            <a:pPr lvl="1"/>
-            <a:r>
-              <a:rPr lang="en-US" dirty="0"/>
+            <a:endParaRPr lang="en-US" sz="2800" b="0" u="none" strike="noStrike">
+              <a:solidFill>
+                <a:schemeClr val="dk1"/>
+              </a:solidFill>
+              <a:effectLst/>
+              <a:uFillTx/>
+              <a:latin typeface="Aptos"/>
+            </a:endParaRPr>
+          </a:p>
+          <a:p>
+            <a:pPr marL="685800" lvl="1" indent="-228600" algn="l" defTabSz="914400">
+              <a:lnSpc>
+                <a:spcPct val="90000"/>
+              </a:lnSpc>
+              <a:spcBef>
+                <a:spcPts val="499"/>
+              </a:spcBef>
+              <a:buClr>
+                <a:srgbClr val="000000"/>
+              </a:buClr>
+              <a:buFont typeface="Arial"/>
+              <a:buChar char="•"/>
+            </a:pPr>
+            <a:r>
+              <a:rPr lang="en-US" sz="2400" b="0" u="none" strike="noStrike">
+                <a:solidFill>
+                  <a:schemeClr val="dk1"/>
+                </a:solidFill>
+                <a:effectLst/>
+                <a:uFillTx/>
+                <a:latin typeface="Aptos"/>
+              </a:rPr>
               <a:t>OpenCV Learning and Testing</a:t>
             </a:r>
-          </a:p>
-          <a:p>
-            <a:pPr lvl="1"/>
-            <a:r>
-              <a:rPr lang="en-US" dirty="0"/>
-              <a:t>Test vehicle components together</a:t>
-            </a:r>
-          </a:p>
-          <a:p>
-            <a:r>
-              <a:rPr lang="en-US" b="1" dirty="0"/>
+            <a:endParaRPr lang="en-US" sz="2400" b="0" u="none" strike="noStrike">
+              <a:solidFill>
+                <a:schemeClr val="dk1"/>
+              </a:solidFill>
+              <a:effectLst/>
+              <a:uFillTx/>
+              <a:latin typeface="Aptos"/>
+            </a:endParaRPr>
+          </a:p>
+          <a:p>
+            <a:pPr marL="685800" lvl="1" indent="-228600" algn="l" defTabSz="914400">
+              <a:lnSpc>
+                <a:spcPct val="90000"/>
+              </a:lnSpc>
+              <a:spcBef>
+                <a:spcPts val="499"/>
+              </a:spcBef>
+              <a:buClr>
+                <a:srgbClr val="000000"/>
+              </a:buClr>
+              <a:buFont typeface="Arial"/>
+              <a:buChar char="•"/>
+            </a:pPr>
+            <a:r>
+              <a:rPr lang="en-US" sz="2400" b="0" u="none" strike="noStrike">
+                <a:solidFill>
+                  <a:schemeClr val="dk1"/>
+                </a:solidFill>
+                <a:effectLst/>
+                <a:uFillTx/>
+                <a:latin typeface="Aptos"/>
+              </a:rPr>
+              <a:t>Test vehicle components together </a:t>
+            </a:r>
+            <a:endParaRPr lang="en-US" sz="2400" b="0" u="none" strike="noStrike">
+              <a:solidFill>
+                <a:schemeClr val="dk1"/>
+              </a:solidFill>
+              <a:effectLst/>
+              <a:uFillTx/>
+              <a:latin typeface="Aptos"/>
+            </a:endParaRPr>
+          </a:p>
+          <a:p>
+            <a:pPr marL="228600" indent="-228600" algn="l" defTabSz="914400">
+              <a:lnSpc>
+                <a:spcPct val="90000"/>
+              </a:lnSpc>
+              <a:spcBef>
+                <a:spcPts val="1001"/>
+              </a:spcBef>
+              <a:buClr>
+                <a:srgbClr val="000000"/>
+              </a:buClr>
+              <a:buFont typeface="Arial"/>
+              <a:buChar char="•"/>
+            </a:pPr>
+            <a:r>
+              <a:rPr lang="en-US" sz="2800" b="1" u="none" strike="noStrike">
+                <a:solidFill>
+                  <a:schemeClr val="dk1"/>
+                </a:solidFill>
+                <a:effectLst/>
+                <a:uFillTx/>
+                <a:latin typeface="Aptos"/>
+              </a:rPr>
               <a:t>Progress for the week</a:t>
             </a:r>
-          </a:p>
-          <a:p>
-            <a:pPr lvl="1"/>
-            <a:r>
-              <a:rPr lang="en-US" dirty="0"/>
+            <a:endParaRPr lang="en-US" sz="2800" b="0" u="none" strike="noStrike">
+              <a:solidFill>
+                <a:schemeClr val="dk1"/>
+              </a:solidFill>
+              <a:effectLst/>
+              <a:uFillTx/>
+              <a:latin typeface="Aptos"/>
+            </a:endParaRPr>
+          </a:p>
+          <a:p>
+            <a:pPr marL="685800" lvl="1" indent="-228600" algn="l" defTabSz="914400">
+              <a:lnSpc>
+                <a:spcPct val="90000"/>
+              </a:lnSpc>
+              <a:spcBef>
+                <a:spcPts val="499"/>
+              </a:spcBef>
+              <a:buClr>
+                <a:srgbClr val="000000"/>
+              </a:buClr>
+              <a:buFont typeface="Arial"/>
+              <a:buChar char="•"/>
+            </a:pPr>
+            <a:r>
+              <a:rPr lang="en-US" sz="2400" b="0" u="none" strike="noStrike">
+                <a:solidFill>
+                  <a:schemeClr val="dk1"/>
+                </a:solidFill>
+                <a:effectLst/>
+                <a:uFillTx/>
+                <a:latin typeface="Aptos"/>
+              </a:rPr>
               <a:t>OpenCV testing on Webcam</a:t>
             </a:r>
-          </a:p>
-          <a:p>
-            <a:pPr lvl="1"/>
-            <a:r>
-              <a:rPr lang="en-US" dirty="0"/>
+            <a:endParaRPr lang="en-US" sz="2400" b="0" u="none" strike="noStrike">
+              <a:solidFill>
+                <a:schemeClr val="dk1"/>
+              </a:solidFill>
+              <a:effectLst/>
+              <a:uFillTx/>
+              <a:latin typeface="Aptos"/>
+            </a:endParaRPr>
+          </a:p>
+          <a:p>
+            <a:pPr marL="685800" lvl="1" indent="-228600" algn="l" defTabSz="914400">
+              <a:lnSpc>
+                <a:spcPct val="90000"/>
+              </a:lnSpc>
+              <a:spcBef>
+                <a:spcPts val="499"/>
+              </a:spcBef>
+              <a:buClr>
+                <a:srgbClr val="000000"/>
+              </a:buClr>
+              <a:buFont typeface="Arial"/>
+              <a:buChar char="•"/>
+            </a:pPr>
+            <a:r>
+              <a:rPr lang="en-US" sz="2400" b="0" u="none" strike="noStrike">
+                <a:solidFill>
+                  <a:schemeClr val="dk1"/>
+                </a:solidFill>
+                <a:effectLst/>
+                <a:uFillTx/>
+                <a:latin typeface="Aptos"/>
+              </a:rPr>
               <a:t>Ordered Chassis to test components</a:t>
             </a:r>
-          </a:p>
-          <a:p>
-            <a:r>
-              <a:rPr lang="en-US" b="1" dirty="0"/>
+            <a:endParaRPr lang="en-US" sz="2400" b="0" u="none" strike="noStrike">
+              <a:solidFill>
+                <a:schemeClr val="dk1"/>
+              </a:solidFill>
+              <a:effectLst/>
+              <a:uFillTx/>
+              <a:latin typeface="Aptos"/>
+            </a:endParaRPr>
+          </a:p>
+          <a:p>
+            <a:pPr marL="228600" indent="-228600" algn="l" defTabSz="914400">
+              <a:lnSpc>
+                <a:spcPct val="90000"/>
+              </a:lnSpc>
+              <a:spcBef>
+                <a:spcPts val="1001"/>
+              </a:spcBef>
+              <a:buClr>
+                <a:srgbClr val="000000"/>
+              </a:buClr>
+              <a:buFont typeface="Arial"/>
+              <a:buChar char="•"/>
+            </a:pPr>
+            <a:r>
+              <a:rPr lang="en-US" sz="2800" b="1" u="none" strike="noStrike">
+                <a:solidFill>
+                  <a:schemeClr val="dk1"/>
+                </a:solidFill>
+                <a:effectLst/>
+                <a:uFillTx/>
+                <a:latin typeface="Aptos"/>
+              </a:rPr>
               <a:t>Goals for next week</a:t>
             </a:r>
-          </a:p>
-          <a:p>
-            <a:pPr lvl="1"/>
-            <a:r>
-              <a:rPr lang="en-US" dirty="0"/>
-              <a:t>Implement OpenCV with </a:t>
-            </a:r>
-            <a:r>
-              <a:rPr lang="en-US" dirty="0" err="1"/>
-              <a:t>RaspberryPi</a:t>
-            </a:r>
-            <a:r>
-              <a:rPr lang="en-US" dirty="0"/>
-              <a:t> Camera</a:t>
-            </a:r>
-          </a:p>
-          <a:p>
-            <a:r>
-              <a:rPr lang="en-US" b="1" dirty="0"/>
+            <a:endParaRPr lang="en-US" sz="2800" b="0" u="none" strike="noStrike">
+              <a:solidFill>
+                <a:schemeClr val="dk1"/>
+              </a:solidFill>
+              <a:effectLst/>
+              <a:uFillTx/>
+              <a:latin typeface="Aptos"/>
+            </a:endParaRPr>
+          </a:p>
+          <a:p>
+            <a:pPr marL="685800" lvl="1" indent="-228600" algn="l" defTabSz="914400">
+              <a:lnSpc>
+                <a:spcPct val="90000"/>
+              </a:lnSpc>
+              <a:spcBef>
+                <a:spcPts val="499"/>
+              </a:spcBef>
+              <a:buClr>
+                <a:srgbClr val="000000"/>
+              </a:buClr>
+              <a:buFont typeface="Arial"/>
+              <a:buChar char="•"/>
+            </a:pPr>
+            <a:r>
+              <a:rPr lang="en-US" sz="2400" b="0" u="none" strike="noStrike">
+                <a:solidFill>
+                  <a:schemeClr val="dk1"/>
+                </a:solidFill>
+                <a:effectLst/>
+                <a:uFillTx/>
+                <a:latin typeface="Aptos"/>
+              </a:rPr>
+              <a:t>Implement OpenCV with RaspberryPi Camera</a:t>
+            </a:r>
+            <a:endParaRPr lang="en-US" sz="2400" b="0" u="none" strike="noStrike">
+              <a:solidFill>
+                <a:schemeClr val="dk1"/>
+              </a:solidFill>
+              <a:effectLst/>
+              <a:uFillTx/>
+              <a:latin typeface="Aptos"/>
+            </a:endParaRPr>
+          </a:p>
+          <a:p>
+            <a:pPr marL="228600" indent="-228600" algn="l" defTabSz="914400">
+              <a:lnSpc>
+                <a:spcPct val="90000"/>
+              </a:lnSpc>
+              <a:spcBef>
+                <a:spcPts val="1001"/>
+              </a:spcBef>
+              <a:buClr>
+                <a:srgbClr val="000000"/>
+              </a:buClr>
+              <a:buFont typeface="Arial"/>
+              <a:buChar char="•"/>
+            </a:pPr>
+            <a:r>
+              <a:rPr lang="en-US" sz="2800" b="1" u="none" strike="noStrike">
+                <a:solidFill>
+                  <a:schemeClr val="dk1"/>
+                </a:solidFill>
+                <a:effectLst/>
+                <a:uFillTx/>
+                <a:latin typeface="Aptos"/>
+              </a:rPr>
               <a:t>Hours spent on progress</a:t>
             </a:r>
-          </a:p>
-          <a:p>
-            <a:pPr lvl="1"/>
-            <a:r>
-              <a:rPr lang="en-US" dirty="0"/>
+            <a:endParaRPr lang="en-US" sz="2800" b="0" u="none" strike="noStrike">
+              <a:solidFill>
+                <a:schemeClr val="dk1"/>
+              </a:solidFill>
+              <a:effectLst/>
+              <a:uFillTx/>
+              <a:latin typeface="Aptos"/>
+            </a:endParaRPr>
+          </a:p>
+          <a:p>
+            <a:pPr marL="685800" lvl="1" indent="-228600" algn="l" defTabSz="914400">
+              <a:lnSpc>
+                <a:spcPct val="90000"/>
+              </a:lnSpc>
+              <a:spcBef>
+                <a:spcPts val="499"/>
+              </a:spcBef>
+              <a:buClr>
+                <a:srgbClr val="000000"/>
+              </a:buClr>
+              <a:buFont typeface="Arial"/>
+              <a:buChar char="•"/>
+            </a:pPr>
+            <a:r>
+              <a:rPr lang="en-US" sz="2400" b="0" u="none" strike="noStrike">
+                <a:solidFill>
+                  <a:schemeClr val="dk1"/>
+                </a:solidFill>
+                <a:effectLst/>
+                <a:uFillTx/>
+                <a:latin typeface="Aptos"/>
+              </a:rPr>
               <a:t>6 hours.</a:t>
             </a:r>
+            <a:endParaRPr lang="en-US" sz="2400" b="0" u="none" strike="noStrike">
+              <a:solidFill>
+                <a:schemeClr val="dk1"/>
+              </a:solidFill>
+              <a:effectLst/>
+              <a:uFillTx/>
+              <a:latin typeface="Aptos"/>
+            </a:endParaRPr>
           </a:p>
         </p:txBody>
       </p:sp>
@@ -13300,33 +14252,64 @@
         <p:nvPr/>
       </p:nvGrpSpPr>
       <p:grpSpPr/>
+      <p:pic>
+        <p:nvPicPr>
+          <p:cNvPr id="2" name="Picture 1" descr="1.jpg"/>
+          <p:cNvPicPr>
+            <a:picLocks noChangeAspect="1"/>
+          </p:cNvPicPr>
+          <p:nvPr/>
+        </p:nvPicPr>
+        <p:blipFill>
+          <a:blip r:embed="rId2"/>
+          <a:stretch>
+            <a:fillRect/>
+          </a:stretch>
+        </p:blipFill>
+        <p:spPr>
+          <a:xfrm>
+            <a:off x="943483" y="0"/>
+            <a:ext cx="10305033" cy="6858000"/>
+          </a:xfrm>
+          <a:prstGeom prst="rect">
+            <a:avLst/>
+          </a:prstGeom>
+        </p:spPr>
+      </p:pic>
+    </p:spTree>
+  </p:cSld>
+  <p:clrMapOvr>
+    <a:masterClrMapping/>
+  </p:clrMapOvr>
+</p:sld>
+</file>
+
+<file path=ppt/slides/slide8.xml><?xml version="1.0" encoding="utf-8"?>
+<p:sld xmlns:a="http://schemas.openxmlformats.org/drawingml/2006/main" xmlns:p="http://schemas.openxmlformats.org/presentationml/2006/main" xmlns:r="http://schemas.openxmlformats.org/officeDocument/2006/relationships">
+  <p:cSld>
+    <p:spTree>
+      <p:nvGrpSpPr>
+        <p:cNvPr id="1" name=""/>
+        <p:cNvGrpSpPr/>
+        <p:nvPr/>
+      </p:nvGrpSpPr>
+      <p:grpSpPr/>
       <p:sp useBgFill="1">
         <p:nvSpPr>
-          <p:cNvPr id="12" name="Rectangle 11">
+          <p:cNvPr id="61" name="Rectangle 11">
             <a:extLst>
-              <a:ext uri="{FF2B5EF4-FFF2-40B4-BE49-F238E27FC236}">
-                <a16:creationId xmlns:a16="http://schemas.microsoft.com/office/drawing/2014/main" id="{F13C74B1-5B17-4795-BED0-7140497B445A}"/>
-              </a:ext>
               <a:ext uri="{C183D7F6-B498-43B3-948B-1728B52AA6E4}">
                 <adec:decorative xmlns:adec="http://schemas.microsoft.com/office/drawing/2017/decorative" val="1"/>
               </a:ext>
             </a:extLst>
           </p:cNvPr>
-          <p:cNvSpPr>
-            <a:spLocks noGrp="1" noRot="1" noChangeAspect="1" noMove="1" noResize="1" noEditPoints="1" noAdjustHandles="1" noChangeArrowheads="1" noChangeShapeType="1" noTextEdit="1"/>
-          </p:cNvSpPr>
-          <p:nvPr>
-            <p:extLst>
-              <p:ext uri="{386F3935-93C4-4BCD-93E2-E3B085C9AB24}">
-                <p16:designElem xmlns:p16="http://schemas.microsoft.com/office/powerpoint/2015/main" val="1"/>
-              </p:ext>
-            </p:extLst>
-          </p:nvPr>
+          <p:cNvSpPr/>
+          <p:nvPr/>
         </p:nvSpPr>
         <p:spPr>
           <a:xfrm>
             <a:off x="0" y="0"/>
-            <a:ext cx="12188952" cy="6858000"/>
+            <a:ext cx="12188520" cy="6857640"/>
           </a:xfrm>
           <a:prstGeom prst="rect">
             <a:avLst/>
@@ -13347,28 +14330,27 @@
           <a:effectRef idx="0">
             <a:schemeClr val="accent1"/>
           </a:effectRef>
-          <a:fontRef idx="minor">
-            <a:schemeClr val="lt1"/>
-          </a:fontRef>
+          <a:fontRef idx="minor"/>
         </p:style>
         <p:txBody>
-          <a:bodyPr rtlCol="0" anchor="ctr"/>
-          <a:lstStyle/>
-          <a:p>
-            <a:pPr algn="ctr"/>
-            <a:endParaRPr lang="en-US"/>
+          <a:bodyPr lIns="90000" tIns="45000" rIns="90000" bIns="45000" anchor="ctr">
+            <a:noAutofit/>
+          </a:bodyPr>
+          <a:p>
+            <a:endParaRPr lang="en-US" sz="1800" b="0" u="none" strike="noStrike">
+              <a:solidFill>
+                <a:schemeClr val="lt1"/>
+              </a:solidFill>
+              <a:effectLst/>
+              <a:uFillTx/>
+              <a:latin typeface="Aptos"/>
+            </a:endParaRPr>
           </a:p>
         </p:txBody>
       </p:sp>
       <p:sp>
         <p:nvSpPr>
-          <p:cNvPr id="2" name="Title 1">
-            <a:extLst>
-              <a:ext uri="{FF2B5EF4-FFF2-40B4-BE49-F238E27FC236}">
-                <a16:creationId xmlns:a16="http://schemas.microsoft.com/office/drawing/2014/main" id="{F8F615E2-3BCF-141C-922F-3366A8E886C5}"/>
-              </a:ext>
-            </a:extLst>
-          </p:cNvPr>
+          <p:cNvPr id="62" name="PlaceHolder 1"/>
           <p:cNvSpPr>
             <a:spLocks noGrp="1"/>
           </p:cNvSpPr>
@@ -13378,126 +14360,146 @@
         </p:nvSpPr>
         <p:spPr>
           <a:xfrm>
-            <a:off x="640080" y="325369"/>
-            <a:ext cx="4368602" cy="1956841"/>
+            <a:off x="640080" y="325440"/>
+            <a:ext cx="4368240" cy="1956600"/>
           </a:xfrm>
+          <a:prstGeom prst="rect">
+            <a:avLst/>
+          </a:prstGeom>
+          <a:noFill/>
+          <a:ln w="0">
+            <a:noFill/>
+          </a:ln>
         </p:spPr>
         <p:txBody>
-          <a:bodyPr anchor="b">
+          <a:bodyPr lIns="91440" tIns="45720" rIns="91440" bIns="45720" anchor="b">
             <a:normAutofit/>
           </a:bodyPr>
-          <a:lstStyle/>
-          <a:p>
-            <a:r>
-              <a:rPr lang="en-US" sz="5400" dirty="0"/>
+          <a:p>
+            <a:pPr indent="0" algn="l" defTabSz="914400">
+              <a:lnSpc>
+                <a:spcPct val="90000"/>
+              </a:lnSpc>
+              <a:buNone/>
+            </a:pPr>
+            <a:r>
+              <a:rPr lang="en-US" sz="5400" b="0" u="none" strike="noStrike">
+                <a:solidFill>
+                  <a:schemeClr val="dk1"/>
+                </a:solidFill>
+                <a:effectLst/>
+                <a:uFillTx/>
+                <a:latin typeface="Aptos Display"/>
+              </a:rPr>
               <a:t>Test Chassis</a:t>
             </a:r>
+            <a:endParaRPr lang="en-US" sz="5400" b="0" u="none" strike="noStrike">
+              <a:solidFill>
+                <a:schemeClr val="dk1"/>
+              </a:solidFill>
+              <a:effectLst/>
+              <a:uFillTx/>
+              <a:latin typeface="Aptos Display"/>
+            </a:endParaRPr>
           </a:p>
         </p:txBody>
       </p:sp>
       <p:sp>
         <p:nvSpPr>
-          <p:cNvPr id="14" name="sketchy line">
+          <p:cNvPr id="63" name="sketchy line">
             <a:extLst>
-              <a:ext uri="{FF2B5EF4-FFF2-40B4-BE49-F238E27FC236}">
-                <a16:creationId xmlns:a16="http://schemas.microsoft.com/office/drawing/2014/main" id="{D4974D33-8DC5-464E-8C6D-BE58F0669C17}"/>
-              </a:ext>
               <a:ext uri="{C183D7F6-B498-43B3-948B-1728B52AA6E4}">
                 <adec:decorative xmlns:adec="http://schemas.microsoft.com/office/drawing/2017/decorative" val="1"/>
               </a:ext>
             </a:extLst>
           </p:cNvPr>
-          <p:cNvSpPr>
-            <a:spLocks noGrp="1" noRot="1" noChangeAspect="1" noMove="1" noResize="1" noEditPoints="1" noAdjustHandles="1" noChangeArrowheads="1" noChangeShapeType="1" noTextEdit="1"/>
-          </p:cNvSpPr>
-          <p:nvPr>
-            <p:extLst>
-              <p:ext uri="{386F3935-93C4-4BCD-93E2-E3B085C9AB24}">
-                <p16:designElem xmlns:p16="http://schemas.microsoft.com/office/powerpoint/2015/main" val="1"/>
-              </p:ext>
-            </p:extLst>
-          </p:nvPr>
+          <p:cNvSpPr/>
+          <p:nvPr/>
         </p:nvSpPr>
         <p:spPr>
           <a:xfrm>
-            <a:off x="640080" y="2586994"/>
-            <a:ext cx="3474720" cy="18288"/>
+            <a:off x="640080" y="2586960"/>
+            <a:ext cx="3474360" cy="18000"/>
           </a:xfrm>
           <a:custGeom>
             <a:avLst/>
             <a:gdLst>
-              <a:gd name="csX0" fmla="*/ 0 w 3474720"/>
-              <a:gd name="csY0" fmla="*/ 0 h 18288"/>
-              <a:gd name="csX1" fmla="*/ 694944 w 3474720"/>
-              <a:gd name="csY1" fmla="*/ 0 h 18288"/>
-              <a:gd name="csX2" fmla="*/ 1355141 w 3474720"/>
-              <a:gd name="csY2" fmla="*/ 0 h 18288"/>
-              <a:gd name="csX3" fmla="*/ 2015338 w 3474720"/>
-              <a:gd name="csY3" fmla="*/ 0 h 18288"/>
-              <a:gd name="csX4" fmla="*/ 2779776 w 3474720"/>
-              <a:gd name="csY4" fmla="*/ 0 h 18288"/>
-              <a:gd name="csX5" fmla="*/ 3474720 w 3474720"/>
-              <a:gd name="csY5" fmla="*/ 0 h 18288"/>
-              <a:gd name="csX6" fmla="*/ 3474720 w 3474720"/>
-              <a:gd name="csY6" fmla="*/ 18288 h 18288"/>
-              <a:gd name="csX7" fmla="*/ 2779776 w 3474720"/>
-              <a:gd name="csY7" fmla="*/ 18288 h 18288"/>
-              <a:gd name="csX8" fmla="*/ 2189074 w 3474720"/>
-              <a:gd name="csY8" fmla="*/ 18288 h 18288"/>
-              <a:gd name="csX9" fmla="*/ 1528877 w 3474720"/>
-              <a:gd name="csY9" fmla="*/ 18288 h 18288"/>
-              <a:gd name="csX10" fmla="*/ 868680 w 3474720"/>
-              <a:gd name="csY10" fmla="*/ 18288 h 18288"/>
-              <a:gd name="csX11" fmla="*/ 0 w 3474720"/>
-              <a:gd name="csY11" fmla="*/ 18288 h 18288"/>
-              <a:gd name="csX12" fmla="*/ 0 w 3474720"/>
-              <a:gd name="csY12" fmla="*/ 0 h 18288"/>
+              <a:gd name="textAreaLeft" fmla="*/ 0 w 3474360"/>
+              <a:gd name="textAreaRight" fmla="*/ 3474720 w 3474360"/>
+              <a:gd name="textAreaTop" fmla="*/ 0 h 18000"/>
+              <a:gd name="textAreaBottom" fmla="*/ 18360 h 18000"/>
+              <a:gd name="GluePoint1X" fmla="*/ 0 w 3474720"/>
+              <a:gd name="GluePoint1Y" fmla="*/ 0 h 18288"/>
+              <a:gd name="GluePoint2X" fmla="*/ 694944 w 3474720"/>
+              <a:gd name="GluePoint2Y" fmla="*/ 0 h 18288"/>
+              <a:gd name="GluePoint3X" fmla="*/ 1355141 w 3474720"/>
+              <a:gd name="GluePoint3Y" fmla="*/ 0 h 18288"/>
+              <a:gd name="GluePoint4X" fmla="*/ 2015338 w 3474720"/>
+              <a:gd name="GluePoint4Y" fmla="*/ 0 h 18288"/>
+              <a:gd name="GluePoint5X" fmla="*/ 2779776 w 3474720"/>
+              <a:gd name="GluePoint5Y" fmla="*/ 0 h 18288"/>
+              <a:gd name="GluePoint6X" fmla="*/ 3474720 w 3474720"/>
+              <a:gd name="GluePoint6Y" fmla="*/ 0 h 18288"/>
+              <a:gd name="GluePoint7X" fmla="*/ 3474720 w 3474720"/>
+              <a:gd name="GluePoint7Y" fmla="*/ 18288 h 18288"/>
+              <a:gd name="GluePoint8X" fmla="*/ 2779776 w 3474720"/>
+              <a:gd name="GluePoint8Y" fmla="*/ 18288 h 18288"/>
+              <a:gd name="GluePoint9X" fmla="*/ 2189074 w 3474720"/>
+              <a:gd name="GluePoint9Y" fmla="*/ 18288 h 18288"/>
+              <a:gd name="GluePoint10X" fmla="*/ 1528877 w 3474720"/>
+              <a:gd name="GluePoint10Y" fmla="*/ 18288 h 18288"/>
+              <a:gd name="GluePoint11X" fmla="*/ 868680 w 3474720"/>
+              <a:gd name="GluePoint11Y" fmla="*/ 18288 h 18288"/>
+              <a:gd name="GluePoint12X" fmla="*/ 0 w 3474720"/>
+              <a:gd name="GluePoint12Y" fmla="*/ 18288 h 18288"/>
+              <a:gd name="GluePoint13X" fmla="*/ 0 w 3474720"/>
+              <a:gd name="GluePoint13Y" fmla="*/ 0 h 18288"/>
             </a:gdLst>
             <a:ahLst/>
             <a:cxnLst>
               <a:cxn ang="0">
-                <a:pos x="csX0" y="csY0"/>
+                <a:pos x="GluePoint1X" y="GluePoint1Y"/>
               </a:cxn>
               <a:cxn ang="0">
-                <a:pos x="csX1" y="csY1"/>
+                <a:pos x="GluePoint2X" y="GluePoint2Y"/>
               </a:cxn>
               <a:cxn ang="0">
-                <a:pos x="csX2" y="csY2"/>
+                <a:pos x="GluePoint3X" y="GluePoint3Y"/>
               </a:cxn>
               <a:cxn ang="0">
-                <a:pos x="csX3" y="csY3"/>
+                <a:pos x="GluePoint4X" y="GluePoint4Y"/>
               </a:cxn>
               <a:cxn ang="0">
-                <a:pos x="csX4" y="csY4"/>
+                <a:pos x="GluePoint5X" y="GluePoint5Y"/>
               </a:cxn>
               <a:cxn ang="0">
-                <a:pos x="csX5" y="csY5"/>
+                <a:pos x="GluePoint6X" y="GluePoint6Y"/>
               </a:cxn>
               <a:cxn ang="0">
-                <a:pos x="csX6" y="csY6"/>
+                <a:pos x="GluePoint7X" y="GluePoint7Y"/>
               </a:cxn>
               <a:cxn ang="0">
-                <a:pos x="csX7" y="csY7"/>
+                <a:pos x="GluePoint8X" y="GluePoint8Y"/>
               </a:cxn>
               <a:cxn ang="0">
-                <a:pos x="csX8" y="csY8"/>
+                <a:pos x="GluePoint9X" y="GluePoint9Y"/>
               </a:cxn>
               <a:cxn ang="0">
-                <a:pos x="csX9" y="csY9"/>
+                <a:pos x="GluePoint10X" y="GluePoint10Y"/>
               </a:cxn>
               <a:cxn ang="0">
-                <a:pos x="csX10" y="csY10"/>
+                <a:pos x="GluePoint11X" y="GluePoint11Y"/>
               </a:cxn>
               <a:cxn ang="0">
-                <a:pos x="csX11" y="csY11"/>
+                <a:pos x="GluePoint12X" y="GluePoint12Y"/>
               </a:cxn>
               <a:cxn ang="0">
-                <a:pos x="csX12" y="csY12"/>
+                <a:pos x="GluePoint13X" y="GluePoint13Y"/>
               </a:cxn>
             </a:cxnLst>
-            <a:rect l="l" t="t" r="r" b="b"/>
+            <a:rect l="textAreaLeft" t="textAreaTop" r="textAreaRight" b="textAreaBottom"/>
             <a:pathLst>
-              <a:path w="3474720" h="18288" fill="none" extrusionOk="0">
+              <a:path fill="none" w="3474720" h="18288">
                 <a:moveTo>
                   <a:pt x="0" y="0"/>
                 </a:moveTo>
@@ -13563,7 +14565,7 @@
                 </a:cubicBezTo>
                 <a:close/>
               </a:path>
-              <a:path w="3474720" h="18288" stroke="0" extrusionOk="0">
+              <a:path stroke="0" w="3474720" h="18288">
                 <a:moveTo>
                   <a:pt x="0" y="0"/>
                 </a:moveTo>
@@ -13634,23 +14636,11 @@
           <a:solidFill>
             <a:schemeClr val="accent2"/>
           </a:solidFill>
-          <a:ln w="44450" cap="rnd">
+          <a:ln cap="rnd" w="44450">
             <a:solidFill>
-              <a:schemeClr val="accent2"/>
+              <a:srgbClr val="E97132"/>
             </a:solidFill>
             <a:round/>
-            <a:extLst>
-              <a:ext uri="{C807C97D-BFC1-408E-A445-0C87EB9F89A2}">
-                <ask:lineSketchStyleProps xmlns:ask="http://schemas.microsoft.com/office/drawing/2018/sketchyshapes" sd="2863741219">
-                  <a:prstGeom prst="rect">
-                    <a:avLst/>
-                  </a:prstGeom>
-                  <ask:type>
-                    <ask:lineSketchFreehand/>
-                  </ask:type>
-                </ask:lineSketchStyleProps>
-              </a:ext>
-            </a:extLst>
           </a:ln>
         </p:spPr>
         <p:style>
@@ -13665,83 +14655,94 @@
           <a:effectRef idx="0">
             <a:schemeClr val="accent1"/>
           </a:effectRef>
-          <a:fontRef idx="minor">
-            <a:schemeClr val="lt1"/>
-          </a:fontRef>
+          <a:fontRef idx="minor"/>
         </p:style>
         <p:txBody>
-          <a:bodyPr rtlCol="0" anchor="ctr"/>
-          <a:lstStyle/>
-          <a:p>
-            <a:pPr algn="ctr"/>
-            <a:endParaRPr lang="en-US"/>
+          <a:bodyPr lIns="90000" tIns="-26640" rIns="90000" bIns="-26640" anchor="ctr">
+            <a:noAutofit/>
+          </a:bodyPr>
+          <a:p>
+            <a:endParaRPr lang="en-US" sz="1800" b="0" u="none" strike="noStrike">
+              <a:solidFill>
+                <a:schemeClr val="lt1"/>
+              </a:solidFill>
+              <a:effectLst/>
+              <a:uFillTx/>
+              <a:latin typeface="Aptos"/>
+            </a:endParaRPr>
           </a:p>
         </p:txBody>
       </p:sp>
       <p:sp>
         <p:nvSpPr>
-          <p:cNvPr id="9" name="Content Placeholder 8">
-            <a:extLst>
-              <a:ext uri="{FF2B5EF4-FFF2-40B4-BE49-F238E27FC236}">
-                <a16:creationId xmlns:a16="http://schemas.microsoft.com/office/drawing/2014/main" id="{7C9F5815-0534-FAE7-A690-5064A383DF3E}"/>
-              </a:ext>
-            </a:extLst>
-          </p:cNvPr>
+          <p:cNvPr id="64" name="PlaceHolder 2"/>
           <p:cNvSpPr>
             <a:spLocks noGrp="1"/>
           </p:cNvSpPr>
           <p:nvPr>
-            <p:ph idx="1"/>
+            <p:ph/>
           </p:nvPr>
         </p:nvSpPr>
         <p:spPr>
           <a:xfrm>
-            <a:off x="640080" y="2872899"/>
-            <a:ext cx="4243589" cy="3320668"/>
+            <a:off x="640080" y="2872800"/>
+            <a:ext cx="4243320" cy="3320280"/>
           </a:xfrm>
+          <a:prstGeom prst="rect">
+            <a:avLst/>
+          </a:prstGeom>
+          <a:noFill/>
+          <a:ln w="0">
+            <a:noFill/>
+          </a:ln>
         </p:spPr>
         <p:txBody>
-          <a:bodyPr>
+          <a:bodyPr lIns="91440" tIns="45720" rIns="91440" bIns="45720" anchor="t">
             <a:normAutofit/>
           </a:bodyPr>
-          <a:lstStyle/>
-          <a:p>
-            <a:endParaRPr lang="en-US" sz="2200" dirty="0"/>
+          <a:p>
+            <a:pPr indent="0" algn="l" defTabSz="914400">
+              <a:lnSpc>
+                <a:spcPct val="90000"/>
+              </a:lnSpc>
+              <a:spcBef>
+                <a:spcPts val="1001"/>
+              </a:spcBef>
+              <a:buNone/>
+            </a:pPr>
+            <a:endParaRPr lang="en-US" sz="2800" b="0" u="none" strike="noStrike">
+              <a:solidFill>
+                <a:schemeClr val="dk1"/>
+              </a:solidFill>
+              <a:effectLst/>
+              <a:uFillTx/>
+              <a:latin typeface="Aptos"/>
+            </a:endParaRPr>
           </a:p>
         </p:txBody>
       </p:sp>
-      <p:pic>
-        <p:nvPicPr>
-          <p:cNvPr id="5" name="Content Placeholder 4">
-            <a:extLst>
-              <a:ext uri="{FF2B5EF4-FFF2-40B4-BE49-F238E27FC236}">
-                <a16:creationId xmlns:a16="http://schemas.microsoft.com/office/drawing/2014/main" id="{CFA3C877-0F59-85E7-79C2-C2AF0EC2A360}"/>
-              </a:ext>
-            </a:extLst>
-          </p:cNvPr>
-          <p:cNvPicPr>
-            <a:picLocks noChangeAspect="1"/>
-          </p:cNvPicPr>
+      <p:sp>
+        <p:nvSpPr>
+          <p:cNvPr id="65" name="Content Placeholder 4"/>
+          <p:cNvSpPr/>
           <p:nvPr/>
-        </p:nvPicPr>
-        <p:blipFill>
-          <a:blip r:embed="rId2"/>
-          <a:srcRect t="302"/>
-          <a:stretch>
-            <a:fillRect/>
-          </a:stretch>
-        </p:blipFill>
+        </p:nvSpPr>
         <p:spPr>
           <a:xfrm>
-            <a:off x="5311702" y="10"/>
-            <a:ext cx="6878775" cy="6857990"/>
+            <a:off x="5311800" y="0"/>
+            <a:ext cx="6878520" cy="6857640"/>
           </a:xfrm>
           <a:custGeom>
             <a:avLst/>
-            <a:gdLst/>
+            <a:gdLst>
+              <a:gd name="textAreaLeft" fmla="*/ 0 w 6878520"/>
+              <a:gd name="textAreaRight" fmla="*/ 6878880 w 6878520"/>
+              <a:gd name="textAreaTop" fmla="*/ 0 h 6857640"/>
+              <a:gd name="textAreaBottom" fmla="*/ 6858000 h 6857640"/>
+            </a:gdLst>
             <a:ahLst/>
             <a:cxnLst/>
-            <a:rect l="l" t="t" r="r" b="b"/>
+            <a:rect l="textAreaLeft" t="textAreaTop" r="textAreaRight" b="textAreaBottom"/>
             <a:pathLst>
               <a:path w="6878775" h="6858000">
                 <a:moveTo>
@@ -13851,8 +14852,37 @@
               </a:path>
             </a:pathLst>
           </a:custGeom>
+          <a:blipFill rotWithShape="0">
+            <a:blip r:embed="rId2"/>
+            <a:srcRect/>
+            <a:stretch/>
+          </a:blipFill>
+          <a:ln w="0">
+            <a:noFill/>
+          </a:ln>
         </p:spPr>
-      </p:pic>
+        <p:style>
+          <a:lnRef idx="0"/>
+          <a:fillRef idx="0"/>
+          <a:effectRef idx="0"/>
+          <a:fontRef idx="minor"/>
+        </p:style>
+        <p:txBody>
+          <a:bodyPr lIns="90000" tIns="45000" rIns="90000" bIns="45000" anchor="t">
+            <a:noAutofit/>
+          </a:bodyPr>
+          <a:p>
+            <a:endParaRPr lang="en-US" sz="1800" b="0" u="none" strike="noStrike">
+              <a:solidFill>
+                <a:srgbClr val="000000"/>
+              </a:solidFill>
+              <a:effectLst/>
+              <a:uFillTx/>
+              <a:latin typeface="Arial"/>
+            </a:endParaRPr>
+          </a:p>
+        </p:txBody>
+      </p:sp>
     </p:spTree>
   </p:cSld>
   <p:clrMapOvr>
@@ -13861,7 +14891,7 @@
 </p:sld>
 </file>
 
-<file path=ppt/slides/slide8.xml><?xml version="1.0" encoding="utf-8"?>
+<file path=ppt/slides/slide9.xml><?xml version="1.0" encoding="utf-8"?>
 <p:sld xmlns:a="http://schemas.openxmlformats.org/drawingml/2006/main" xmlns:p="http://schemas.openxmlformats.org/presentationml/2006/main" xmlns:r="http://schemas.openxmlformats.org/officeDocument/2006/relationships">
   <p:cSld>
     <p:spTree>
@@ -13996,658 +15026,6 @@
             <a:r>
               <a:rPr dirty="0"/>
               <a:t> hours.</a:t>
-            </a:r>
-          </a:p>
-        </p:txBody>
-      </p:sp>
-    </p:spTree>
-  </p:cSld>
-  <p:clrMapOvr>
-    <a:masterClrMapping/>
-  </p:clrMapOvr>
-</p:sld>
-</file>
-
-<file path=ppt/slides/slide9.xml><?xml version="1.0" encoding="utf-8"?>
-<p:sld xmlns:a="http://schemas.openxmlformats.org/drawingml/2006/main" xmlns:p="http://schemas.openxmlformats.org/presentationml/2006/main" xmlns:r="http://schemas.openxmlformats.org/officeDocument/2006/relationships">
-  <p:cSld>
-    <p:spTree>
-      <p:nvGrpSpPr>
-        <p:cNvPr id="1" name=""/>
-        <p:cNvGrpSpPr/>
-        <p:nvPr/>
-      </p:nvGrpSpPr>
-      <p:grpSpPr/>
-      <p:sp>
-        <p:nvSpPr>
-          <p:cNvPr id="2" name="Title"/>
-          <p:cNvSpPr>
-            <a:spLocks noGrp="1"/>
-          </p:cNvSpPr>
-          <p:nvPr>
-            <p:ph type="title"/>
-          </p:nvPr>
-        </p:nvSpPr>
-        <p:spPr>
-          <a:xfrm>
-            <a:off x="768096" y="365760"/>
-            <a:ext cx="10789920" cy="658368"/>
-          </a:xfrm>
-        </p:spPr>
-        <p:txBody>
-          <a:bodyPr lIns="0" tIns="0" rIns="0" bIns="0" anchor="b">
-            <a:normAutofit/>
-          </a:bodyPr>
-          <a:lstStyle/>
-          <a:p>
-            <a:pPr algn="l"/>
-            <a:r>
-              <a:rPr lang="en-US" sz="3500" b="0" dirty="0">
-                <a:solidFill>
-                  <a:srgbClr val="000000"/>
-                </a:solidFill>
-                <a:latin typeface="Aptos Display"/>
-                <a:ea typeface="Aptos Display"/>
-                <a:cs typeface="Aptos Display"/>
-              </a:rPr>
-              <a:t>ROS 2 could split our pipeline into eight nodes</a:t>
-            </a:r>
-          </a:p>
-        </p:txBody>
-      </p:sp>
-      <p:sp>
-        <p:nvSpPr>
-          <p:cNvPr id="3" name="Subtitle"/>
-          <p:cNvSpPr txBox="1"/>
-          <p:nvPr/>
-        </p:nvSpPr>
-        <p:spPr>
-          <a:xfrm>
-            <a:off x="786384" y="1024128"/>
-            <a:ext cx="10607040" cy="365760"/>
-          </a:xfrm>
-          <a:prstGeom prst="rect">
-            <a:avLst/>
-          </a:prstGeom>
-          <a:noFill/>
-        </p:spPr>
-        <p:txBody>
-          <a:bodyPr wrap="square" lIns="0" tIns="0" rIns="0" bIns="0" anchor="t">
-            <a:noAutofit/>
-          </a:bodyPr>
-          <a:lstStyle/>
-          <a:p>
-            <a:pPr marL="0" indent="0" algn="l">
-              <a:spcBef>
-                <a:spcPts val="0"/>
-              </a:spcBef>
-              <a:buNone/>
-            </a:pPr>
-            <a:r>
-              <a:rPr lang="en-US" sz="1500" b="1" dirty="0">
-                <a:solidFill>
-                  <a:srgbClr val="000000"/>
-                </a:solidFill>
-                <a:latin typeface="Aptos"/>
-                <a:ea typeface="Aptos"/>
-                <a:cs typeface="Aptos"/>
-              </a:rPr>
-              <a:t>Preliminary node structure for the car; each node does one job</a:t>
-            </a:r>
-          </a:p>
-        </p:txBody>
-      </p:sp>
-      <p:sp>
-        <p:nvSpPr>
-          <p:cNvPr id="4" name="Nodes"/>
-          <p:cNvSpPr txBox="1"/>
-          <p:nvPr/>
-        </p:nvSpPr>
-        <p:spPr>
-          <a:xfrm>
-            <a:off x="786384" y="1719072"/>
-            <a:ext cx="6309360" cy="384048"/>
-          </a:xfrm>
-          <a:prstGeom prst="rect">
-            <a:avLst/>
-          </a:prstGeom>
-          <a:noFill/>
-        </p:spPr>
-        <p:txBody>
-          <a:bodyPr wrap="square" lIns="0" tIns="0" rIns="0" bIns="0" anchor="t">
-            <a:noAutofit/>
-          </a:bodyPr>
-          <a:lstStyle/>
-          <a:p>
-            <a:pPr marL="0" indent="0" algn="l">
-              <a:spcBef>
-                <a:spcPts val="0"/>
-              </a:spcBef>
-              <a:buNone/>
-            </a:pPr>
-            <a:r>
-              <a:rPr lang="en-US" sz="1950" b="1" dirty="0">
-                <a:solidFill>
-                  <a:srgbClr val="30669D"/>
-                </a:solidFill>
-                <a:latin typeface="Aptos"/>
-                <a:ea typeface="Aptos"/>
-                <a:cs typeface="Aptos"/>
-              </a:rPr>
-              <a:t>Nodes</a:t>
-            </a:r>
-          </a:p>
-        </p:txBody>
-      </p:sp>
-      <p:sp>
-        <p:nvSpPr>
-          <p:cNvPr id="5" name="Node list"/>
-          <p:cNvSpPr txBox="1"/>
-          <p:nvPr/>
-        </p:nvSpPr>
-        <p:spPr>
-          <a:xfrm>
-            <a:off x="786384" y="2240280"/>
-            <a:ext cx="6309360" cy="4023360"/>
-          </a:xfrm>
-          <a:prstGeom prst="rect">
-            <a:avLst/>
-          </a:prstGeom>
-          <a:noFill/>
-        </p:spPr>
-        <p:txBody>
-          <a:bodyPr wrap="square" lIns="0" tIns="0" rIns="0" bIns="0" anchor="t">
-            <a:noAutofit/>
-          </a:bodyPr>
-          <a:lstStyle/>
-          <a:p>
-            <a:pPr marL="228600" indent="-228600" algn="l">
-              <a:spcBef>
-                <a:spcPts val="0"/>
-              </a:spcBef>
-              <a:buClr>
-                <a:srgbClr val="30669D"/>
-              </a:buClr>
-              <a:buFont typeface="Arial"/>
-              <a:buChar char="•"/>
-            </a:pPr>
-            <a:r>
-              <a:rPr lang="en-US" sz="1600" b="1" dirty="0">
-                <a:solidFill>
-                  <a:srgbClr val="000000"/>
-                </a:solidFill>
-                <a:latin typeface="Aptos"/>
-                <a:ea typeface="Aptos"/>
-                <a:cs typeface="Aptos"/>
-              </a:rPr>
-              <a:t>Camera: </a:t>
-            </a:r>
-            <a:r>
-              <a:rPr lang="en-US" sz="1600" b="0" dirty="0">
-                <a:solidFill>
-                  <a:srgbClr val="000000"/>
-                </a:solidFill>
-                <a:latin typeface="Aptos"/>
-                <a:ea typeface="Aptos"/>
-                <a:cs typeface="Aptos"/>
-              </a:rPr>
-              <a:t>streams video from the Pi Camera Module 3</a:t>
-            </a:r>
-          </a:p>
-          <a:p>
-            <a:pPr marL="228600" indent="-228600" algn="l">
-              <a:spcBef>
-                <a:spcPts val="700"/>
-              </a:spcBef>
-              <a:buClr>
-                <a:srgbClr val="30669D"/>
-              </a:buClr>
-              <a:buFont typeface="Arial"/>
-              <a:buChar char="•"/>
-            </a:pPr>
-            <a:r>
-              <a:rPr lang="en-US" sz="1600" b="1" dirty="0">
-                <a:solidFill>
-                  <a:srgbClr val="000000"/>
-                </a:solidFill>
-                <a:latin typeface="Aptos"/>
-                <a:ea typeface="Aptos"/>
-                <a:cs typeface="Aptos"/>
-              </a:rPr>
-              <a:t>Sign detector: </a:t>
-            </a:r>
-            <a:r>
-              <a:rPr lang="en-US" sz="1600" b="0" dirty="0">
-                <a:solidFill>
-                  <a:srgbClr val="000000"/>
-                </a:solidFill>
-                <a:latin typeface="Aptos"/>
-                <a:ea typeface="Aptos"/>
-                <a:cs typeface="Aptos"/>
-              </a:rPr>
-              <a:t>runs the vision model and reports each sign’s type, confidence and position</a:t>
-            </a:r>
-          </a:p>
-          <a:p>
-            <a:pPr marL="228600" indent="-228600" algn="l">
-              <a:spcBef>
-                <a:spcPts val="700"/>
-              </a:spcBef>
-              <a:buClr>
-                <a:srgbClr val="30669D"/>
-              </a:buClr>
-              <a:buFont typeface="Arial"/>
-              <a:buChar char="•"/>
-            </a:pPr>
-            <a:r>
-              <a:rPr lang="en-US" sz="1600" b="1" dirty="0">
-                <a:solidFill>
-                  <a:srgbClr val="000000"/>
-                </a:solidFill>
-                <a:latin typeface="Aptos"/>
-                <a:ea typeface="Aptos"/>
-                <a:cs typeface="Aptos"/>
-              </a:rPr>
-              <a:t>Line sensor: </a:t>
-            </a:r>
-            <a:r>
-              <a:rPr lang="en-US" sz="1600" b="0" dirty="0">
-                <a:solidFill>
-                  <a:srgbClr val="000000"/>
-                </a:solidFill>
-                <a:latin typeface="Aptos"/>
-                <a:ea typeface="Aptos"/>
-                <a:cs typeface="Aptos"/>
-              </a:rPr>
-              <a:t>tracks the lane lines with TCRT5000 IR sensors</a:t>
-            </a:r>
-          </a:p>
-          <a:p>
-            <a:pPr marL="228600" indent="-228600" algn="l">
-              <a:spcBef>
-                <a:spcPts val="700"/>
-              </a:spcBef>
-              <a:buClr>
-                <a:srgbClr val="30669D"/>
-              </a:buClr>
-              <a:buFont typeface="Arial"/>
-              <a:buChar char="•"/>
-            </a:pPr>
-            <a:r>
-              <a:rPr lang="en-US" sz="1600" b="1" dirty="0">
-                <a:solidFill>
-                  <a:srgbClr val="000000"/>
-                </a:solidFill>
-                <a:latin typeface="Aptos"/>
-                <a:ea typeface="Aptos"/>
-                <a:cs typeface="Aptos"/>
-              </a:rPr>
-              <a:t>IMU: </a:t>
-            </a:r>
-            <a:r>
-              <a:rPr lang="en-US" sz="1600" b="0" dirty="0">
-                <a:solidFill>
-                  <a:srgbClr val="000000"/>
-                </a:solidFill>
-                <a:latin typeface="Aptos"/>
-                <a:ea typeface="Aptos"/>
-                <a:cs typeface="Aptos"/>
-              </a:rPr>
-              <a:t>reports turning and motion; detects if the car is stuck</a:t>
-            </a:r>
-          </a:p>
-          <a:p>
-            <a:pPr marL="228600" indent="-228600" algn="l">
-              <a:spcBef>
-                <a:spcPts val="700"/>
-              </a:spcBef>
-              <a:buClr>
-                <a:srgbClr val="30669D"/>
-              </a:buClr>
-              <a:buFont typeface="Arial"/>
-              <a:buChar char="•"/>
-            </a:pPr>
-            <a:r>
-              <a:rPr lang="en-US" sz="1600" b="1" dirty="0">
-                <a:solidFill>
-                  <a:srgbClr val="000000"/>
-                </a:solidFill>
-                <a:latin typeface="Aptos"/>
-                <a:ea typeface="Aptos"/>
-                <a:cs typeface="Aptos"/>
-              </a:rPr>
-              <a:t>Behavior: </a:t>
-            </a:r>
-            <a:r>
-              <a:rPr lang="en-US" sz="1600" b="0" dirty="0">
-                <a:solidFill>
-                  <a:srgbClr val="000000"/>
-                </a:solidFill>
-                <a:latin typeface="Aptos"/>
-                <a:ea typeface="Aptos"/>
-                <a:cs typeface="Aptos"/>
-              </a:rPr>
-              <a:t>a state machine that turns signs, lane position and IMU data into driving decisions</a:t>
-            </a:r>
-          </a:p>
-          <a:p>
-            <a:pPr marL="228600" indent="-228600" algn="l">
-              <a:spcBef>
-                <a:spcPts val="700"/>
-              </a:spcBef>
-              <a:buClr>
-                <a:srgbClr val="30669D"/>
-              </a:buClr>
-              <a:buFont typeface="Arial"/>
-              <a:buChar char="•"/>
-            </a:pPr>
-            <a:r>
-              <a:rPr lang="en-US" sz="1600" b="1" dirty="0">
-                <a:solidFill>
-                  <a:srgbClr val="000000"/>
-                </a:solidFill>
-                <a:latin typeface="Aptos"/>
-                <a:ea typeface="Aptos"/>
-                <a:cs typeface="Aptos"/>
-              </a:rPr>
-              <a:t>Motor driver: </a:t>
-            </a:r>
-            <a:r>
-              <a:rPr lang="en-US" sz="1600" b="0" dirty="0">
-                <a:solidFill>
-                  <a:srgbClr val="000000"/>
-                </a:solidFill>
-                <a:latin typeface="Aptos"/>
-                <a:ea typeface="Aptos"/>
-                <a:cs typeface="Aptos"/>
-              </a:rPr>
-              <a:t>drives the wheels through the Waveshare HAT and stops if commands stop arriving</a:t>
-            </a:r>
-          </a:p>
-          <a:p>
-            <a:pPr marL="228600" indent="-228600" algn="l">
-              <a:spcBef>
-                <a:spcPts val="700"/>
-              </a:spcBef>
-              <a:buClr>
-                <a:srgbClr val="30669D"/>
-              </a:buClr>
-              <a:buFont typeface="Arial"/>
-              <a:buChar char="•"/>
-            </a:pPr>
-            <a:r>
-              <a:rPr lang="en-US" sz="1600" b="1" dirty="0">
-                <a:solidFill>
-                  <a:srgbClr val="000000"/>
-                </a:solidFill>
-                <a:latin typeface="Aptos"/>
-                <a:ea typeface="Aptos"/>
-                <a:cs typeface="Aptos"/>
-              </a:rPr>
-              <a:t>LCD: </a:t>
-            </a:r>
-            <a:r>
-              <a:rPr lang="en-US" sz="1600" b="0" dirty="0">
-                <a:solidFill>
-                  <a:srgbClr val="000000"/>
-                </a:solidFill>
-                <a:latin typeface="Aptos"/>
-                <a:ea typeface="Aptos"/>
-                <a:cs typeface="Aptos"/>
-              </a:rPr>
-              <a:t>shows the car’s state and the last sign detected</a:t>
-            </a:r>
-          </a:p>
-          <a:p>
-            <a:pPr marL="228600" indent="-228600" algn="l">
-              <a:spcBef>
-                <a:spcPts val="700"/>
-              </a:spcBef>
-              <a:buClr>
-                <a:srgbClr val="30669D"/>
-              </a:buClr>
-              <a:buFont typeface="Arial"/>
-              <a:buChar char="•"/>
-            </a:pPr>
-            <a:r>
-              <a:rPr lang="en-US" sz="1600" b="1" dirty="0">
-                <a:solidFill>
-                  <a:srgbClr val="000000"/>
-                </a:solidFill>
-                <a:latin typeface="Aptos"/>
-                <a:ea typeface="Aptos"/>
-                <a:cs typeface="Aptos"/>
-              </a:rPr>
-              <a:t>Teleop: </a:t>
-            </a:r>
-            <a:r>
-              <a:rPr lang="en-US" sz="1600" b="0" dirty="0">
-                <a:solidFill>
-                  <a:srgbClr val="000000"/>
-                </a:solidFill>
-                <a:latin typeface="Aptos"/>
-                <a:ea typeface="Aptos"/>
-                <a:cs typeface="Aptos"/>
-              </a:rPr>
-              <a:t>lets a person take over and drive manually</a:t>
-            </a:r>
-          </a:p>
-        </p:txBody>
-      </p:sp>
-      <p:sp>
-        <p:nvSpPr>
-          <p:cNvPr id="6" name="Why ROS 2"/>
-          <p:cNvSpPr txBox="1"/>
-          <p:nvPr/>
-        </p:nvSpPr>
-        <p:spPr>
-          <a:xfrm>
-            <a:off x="7635240" y="1719072"/>
-            <a:ext cx="3794760" cy="384048"/>
-          </a:xfrm>
-          <a:prstGeom prst="rect">
-            <a:avLst/>
-          </a:prstGeom>
-          <a:noFill/>
-        </p:spPr>
-        <p:txBody>
-          <a:bodyPr wrap="square" lIns="0" tIns="0" rIns="0" bIns="0" anchor="t">
-            <a:noAutofit/>
-          </a:bodyPr>
-          <a:lstStyle/>
-          <a:p>
-            <a:pPr marL="0" indent="0" algn="l">
-              <a:spcBef>
-                <a:spcPts val="0"/>
-              </a:spcBef>
-              <a:buNone/>
-            </a:pPr>
-            <a:r>
-              <a:rPr lang="en-US" sz="1950" b="1" dirty="0">
-                <a:solidFill>
-                  <a:srgbClr val="30669D"/>
-                </a:solidFill>
-                <a:latin typeface="Aptos"/>
-                <a:ea typeface="Aptos"/>
-                <a:cs typeface="Aptos"/>
-              </a:rPr>
-              <a:t>Why ROS 2</a:t>
-            </a:r>
-          </a:p>
-        </p:txBody>
-      </p:sp>
-      <p:sp>
-        <p:nvSpPr>
-          <p:cNvPr id="7" name="Why ROS 2 list"/>
-          <p:cNvSpPr txBox="1"/>
-          <p:nvPr/>
-        </p:nvSpPr>
-        <p:spPr>
-          <a:xfrm>
-            <a:off x="7635240" y="2240280"/>
-            <a:ext cx="3794760" cy="2103120"/>
-          </a:xfrm>
-          <a:prstGeom prst="rect">
-            <a:avLst/>
-          </a:prstGeom>
-          <a:noFill/>
-        </p:spPr>
-        <p:txBody>
-          <a:bodyPr wrap="square" lIns="0" tIns="0" rIns="0" bIns="0" anchor="t">
-            <a:noAutofit/>
-          </a:bodyPr>
-          <a:lstStyle/>
-          <a:p>
-            <a:pPr marL="228600" indent="-228600" algn="l">
-              <a:spcBef>
-                <a:spcPts val="0"/>
-              </a:spcBef>
-              <a:buClr>
-                <a:srgbClr val="30669D"/>
-              </a:buClr>
-              <a:buFont typeface="Arial"/>
-              <a:buChar char="•"/>
-            </a:pPr>
-            <a:r>
-              <a:rPr lang="en-US" sz="1600" b="0" dirty="0">
-                <a:solidFill>
-                  <a:srgbClr val="000000"/>
-                </a:solidFill>
-                <a:latin typeface="Aptos"/>
-                <a:ea typeface="Aptos"/>
-                <a:cs typeface="Aptos"/>
-              </a:rPr>
-              <a:t>Each teammate can own a node without touching the others</a:t>
-            </a:r>
-          </a:p>
-          <a:p>
-            <a:pPr marL="228600" indent="-228600" algn="l">
-              <a:spcBef>
-                <a:spcPts val="900"/>
-              </a:spcBef>
-              <a:buClr>
-                <a:srgbClr val="30669D"/>
-              </a:buClr>
-              <a:buFont typeface="Arial"/>
-              <a:buChar char="•"/>
-            </a:pPr>
-            <a:r>
-              <a:rPr lang="en-US" sz="1600" b="0" dirty="0">
-                <a:solidFill>
-                  <a:srgbClr val="000000"/>
-                </a:solidFill>
-                <a:latin typeface="Aptos"/>
-                <a:ea typeface="Aptos"/>
-                <a:cs typeface="Aptos"/>
-              </a:rPr>
-              <a:t>Recorded drives can be replayed to test without the car</a:t>
-            </a:r>
-          </a:p>
-          <a:p>
-            <a:pPr marL="228600" indent="-228600" algn="l">
-              <a:spcBef>
-                <a:spcPts val="900"/>
-              </a:spcBef>
-              <a:buClr>
-                <a:srgbClr val="30669D"/>
-              </a:buClr>
-              <a:buFont typeface="Arial"/>
-              <a:buChar char="•"/>
-            </a:pPr>
-            <a:r>
-              <a:rPr lang="en-US" sz="1600" b="0" dirty="0">
-                <a:solidFill>
-                  <a:srgbClr val="000000"/>
-                </a:solidFill>
-                <a:latin typeface="Aptos"/>
-                <a:ea typeface="Aptos"/>
-                <a:cs typeface="Aptos"/>
-              </a:rPr>
-              <a:t>Laptops can watch the camera feed and topics live</a:t>
-            </a:r>
-          </a:p>
-        </p:txBody>
-      </p:sp>
-      <p:sp>
-        <p:nvSpPr>
-          <p:cNvPr id="8" name="Trade-off"/>
-          <p:cNvSpPr txBox="1"/>
-          <p:nvPr/>
-        </p:nvSpPr>
-        <p:spPr>
-          <a:xfrm>
-            <a:off x="7635240" y="4434840"/>
-            <a:ext cx="3794760" cy="384048"/>
-          </a:xfrm>
-          <a:prstGeom prst="rect">
-            <a:avLst/>
-          </a:prstGeom>
-          <a:noFill/>
-        </p:spPr>
-        <p:txBody>
-          <a:bodyPr wrap="square" lIns="0" tIns="0" rIns="0" bIns="0" anchor="t">
-            <a:noAutofit/>
-          </a:bodyPr>
-          <a:lstStyle/>
-          <a:p>
-            <a:pPr marL="0" indent="0" algn="l">
-              <a:spcBef>
-                <a:spcPts val="0"/>
-              </a:spcBef>
-              <a:buNone/>
-            </a:pPr>
-            <a:r>
-              <a:rPr lang="en-US" sz="1950" b="1" dirty="0">
-                <a:solidFill>
-                  <a:srgbClr val="30669D"/>
-                </a:solidFill>
-                <a:latin typeface="Aptos"/>
-                <a:ea typeface="Aptos"/>
-                <a:cs typeface="Aptos"/>
-              </a:rPr>
-              <a:t>Trade-off</a:t>
-            </a:r>
-          </a:p>
-        </p:txBody>
-      </p:sp>
-      <p:sp>
-        <p:nvSpPr>
-          <p:cNvPr id="9" name="Trade-off text"/>
-          <p:cNvSpPr txBox="1"/>
-          <p:nvPr/>
-        </p:nvSpPr>
-        <p:spPr>
-          <a:xfrm>
-            <a:off x="7635240" y="4956048"/>
-            <a:ext cx="3794760" cy="1280160"/>
-          </a:xfrm>
-          <a:prstGeom prst="rect">
-            <a:avLst/>
-          </a:prstGeom>
-          <a:noFill/>
-        </p:spPr>
-        <p:txBody>
-          <a:bodyPr wrap="square" lIns="0" tIns="0" rIns="0" bIns="0" anchor="t">
-            <a:noAutofit/>
-          </a:bodyPr>
-          <a:lstStyle/>
-          <a:p>
-            <a:pPr marL="0" indent="0" algn="l">
-              <a:spcBef>
-                <a:spcPts val="0"/>
-              </a:spcBef>
-              <a:buNone/>
-            </a:pPr>
-            <a:r>
-              <a:rPr lang="en-US" sz="1600" b="0" dirty="0">
-                <a:solidFill>
-                  <a:srgbClr val="000000"/>
-                </a:solidFill>
-                <a:latin typeface="Aptos"/>
-                <a:ea typeface="Aptos"/>
-                <a:cs typeface="Aptos"/>
-              </a:rPr>
-              <a:t>More upfront setup than a single script, including a custom Docker build for the CM5 camera</a:t>
             </a:r>
           </a:p>
         </p:txBody>

</xml_diff>